<commit_message>
searchnet v0.9.3 release snapshot
Documentation and terminology release. No engine change.

Cut because the public repo was still serving "Realised epistasis of a
simulated system is measured as K_CC" -- not through any missed edit, but
because public-release was the v0.9.2 snapshot and the correction landed on
dev after it. Snapshots advance only at release, so a release was the fix.

Excluded via .public-exclude: CLAUDE.md, docs/CROSS_PROJECT_SYNC.md,
docs/COMMERCIALIZATION_BRAINSTORM.md, docs/FEATURE_ROADMAP.md.
Gate: 693 tracked paths, clean.

Co-Authored-By: Claude Opus 5 <noreply@anthropic.com>
</commit_message>
<xml_diff>
--- a/docs/searchnet_PDW_slides.pptx
+++ b/docs/searchnet_PDW_slides.pptx
@@ -32728,7 +32728,7 @@
         <p:spPr>
           <a:xfrm>
             <a:off x="1188720" y="1783080"/>
-            <a:ext cx="1080721" cy="256032"/>
+            <a:ext cx="1172816" cy="256032"/>
           </a:xfrm>
           <a:prstGeom prst="rect">
             <a:avLst/>
@@ -32747,8 +32747,8 @@
         </p:nvSpPr>
         <p:spPr>
           <a:xfrm>
-            <a:off x="2269441" y="1783080"/>
-            <a:ext cx="1361661" cy="256032"/>
+            <a:off x="2361536" y="1783080"/>
+            <a:ext cx="1439148" cy="256032"/>
           </a:xfrm>
           <a:prstGeom prst="rect">
             <a:avLst/>
@@ -32767,8 +32767,8 @@
         </p:nvSpPr>
         <p:spPr>
           <a:xfrm>
-            <a:off x="3631102" y="1783080"/>
-            <a:ext cx="619053" cy="256032"/>
+            <a:off x="3800684" y="1783080"/>
+            <a:ext cx="862591" cy="256032"/>
           </a:xfrm>
           <a:prstGeom prst="rect">
             <a:avLst/>
@@ -32787,8 +32787,8 @@
         </p:nvSpPr>
         <p:spPr>
           <a:xfrm>
-            <a:off x="4250155" y="1783080"/>
-            <a:ext cx="911764" cy="256032"/>
+            <a:off x="4663275" y="1783080"/>
+            <a:ext cx="531341" cy="256032"/>
           </a:xfrm>
           <a:prstGeom prst="rect">
             <a:avLst/>
@@ -32807,8 +32807,8 @@
         </p:nvSpPr>
         <p:spPr>
           <a:xfrm>
-            <a:off x="5161919" y="1783080"/>
-            <a:ext cx="277773" cy="256032"/>
+            <a:off x="5194616" y="1783080"/>
+            <a:ext cx="384534" cy="256032"/>
           </a:xfrm>
           <a:prstGeom prst="rect">
             <a:avLst/>
@@ -32867,7 +32867,7 @@
         <p:spPr>
           <a:xfrm>
             <a:off x="1188720" y="2103120"/>
-            <a:ext cx="1011321" cy="256032"/>
+            <a:ext cx="1009120" cy="256032"/>
           </a:xfrm>
           <a:prstGeom prst="rect">
             <a:avLst/>
@@ -32886,8 +32886,8 @@
         </p:nvSpPr>
         <p:spPr>
           <a:xfrm>
-            <a:off x="2200041" y="2103120"/>
-            <a:ext cx="1223561" cy="256032"/>
+            <a:off x="2197840" y="2103120"/>
+            <a:ext cx="1143114" cy="256032"/>
           </a:xfrm>
           <a:prstGeom prst="rect">
             <a:avLst/>
@@ -32906,8 +32906,8 @@
         </p:nvSpPr>
         <p:spPr>
           <a:xfrm>
-            <a:off x="3423602" y="2103120"/>
-            <a:ext cx="647418" cy="256032"/>
+            <a:off x="3340954" y="2103120"/>
+            <a:ext cx="643226" cy="256032"/>
           </a:xfrm>
           <a:prstGeom prst="rect">
             <a:avLst/>
@@ -32926,8 +32926,8 @@
         </p:nvSpPr>
         <p:spPr>
           <a:xfrm>
-            <a:off x="4071020" y="2103120"/>
-            <a:ext cx="826429" cy="256032"/>
+            <a:off x="3984179" y="2103120"/>
+            <a:ext cx="752045" cy="256032"/>
           </a:xfrm>
           <a:prstGeom prst="rect">
             <a:avLst/>
@@ -32946,8 +32946,8 @@
         </p:nvSpPr>
         <p:spPr>
           <a:xfrm>
-            <a:off x="4897449" y="2103120"/>
-            <a:ext cx="496938" cy="256032"/>
+            <a:off x="4736225" y="2103120"/>
+            <a:ext cx="430103" cy="256032"/>
           </a:xfrm>
           <a:prstGeom prst="rect">
             <a:avLst/>
@@ -33006,7 +33006,7 @@
         <p:spPr>
           <a:xfrm>
             <a:off x="1188720" y="2423160"/>
-            <a:ext cx="1069429" cy="256032"/>
+            <a:ext cx="1094403" cy="256032"/>
           </a:xfrm>
           <a:prstGeom prst="rect">
             <a:avLst/>
@@ -33025,8 +33025,8 @@
         </p:nvSpPr>
         <p:spPr>
           <a:xfrm>
-            <a:off x="2258149" y="2423160"/>
-            <a:ext cx="1202009" cy="256032"/>
+            <a:off x="2283123" y="2423160"/>
+            <a:ext cx="1204250" cy="256032"/>
           </a:xfrm>
           <a:prstGeom prst="rect">
             <a:avLst/>
@@ -33045,8 +33045,8 @@
         </p:nvSpPr>
         <p:spPr>
           <a:xfrm>
-            <a:off x="3460158" y="2423160"/>
-            <a:ext cx="644982" cy="256032"/>
+            <a:off x="3487372" y="2423160"/>
+            <a:ext cx="767546" cy="256032"/>
           </a:xfrm>
           <a:prstGeom prst="rect">
             <a:avLst/>
@@ -33065,8 +33065,8 @@
         </p:nvSpPr>
         <p:spPr>
           <a:xfrm>
-            <a:off x="4105140" y="2423160"/>
-            <a:ext cx="941089" cy="256032"/>
+            <a:off x="4254918" y="2423160"/>
+            <a:ext cx="690660" cy="256032"/>
           </a:xfrm>
           <a:prstGeom prst="rect">
             <a:avLst/>
@@ -33085,8 +33085,8 @@
         </p:nvSpPr>
         <p:spPr>
           <a:xfrm>
-            <a:off x="5046230" y="2423160"/>
-            <a:ext cx="376138" cy="256032"/>
+            <a:off x="4945578" y="2423160"/>
+            <a:ext cx="494184" cy="256032"/>
           </a:xfrm>
           <a:prstGeom prst="rect">
             <a:avLst/>
@@ -33145,7 +33145,7 @@
         <p:spPr>
           <a:xfrm>
             <a:off x="1188720" y="2743200"/>
-            <a:ext cx="925723" cy="256032"/>
+            <a:ext cx="1107825" cy="256032"/>
           </a:xfrm>
           <a:prstGeom prst="rect">
             <a:avLst/>
@@ -33164,8 +33164,8 @@
         </p:nvSpPr>
         <p:spPr>
           <a:xfrm>
-            <a:off x="2114443" y="2743200"/>
-            <a:ext cx="1141064" cy="256032"/>
+            <a:off x="2296545" y="2743200"/>
+            <a:ext cx="1286804" cy="256032"/>
           </a:xfrm>
           <a:prstGeom prst="rect">
             <a:avLst/>
@@ -33184,8 +33184,8 @@
         </p:nvSpPr>
         <p:spPr>
           <a:xfrm>
-            <a:off x="3255507" y="2743200"/>
-            <a:ext cx="620642" cy="256032"/>
+            <a:off x="3583349" y="2743200"/>
+            <a:ext cx="807153" cy="256032"/>
           </a:xfrm>
           <a:prstGeom prst="rect">
             <a:avLst/>
@@ -33204,8 +33204,8 @@
         </p:nvSpPr>
         <p:spPr>
           <a:xfrm>
-            <a:off x="3876149" y="2743200"/>
-            <a:ext cx="848564" cy="256032"/>
+            <a:off x="4390502" y="2743200"/>
+            <a:ext cx="651175" cy="256032"/>
           </a:xfrm>
           <a:prstGeom prst="rect">
             <a:avLst/>
@@ -33224,8 +33224,8 @@
         </p:nvSpPr>
         <p:spPr>
           <a:xfrm>
-            <a:off x="4724713" y="2743200"/>
-            <a:ext cx="502314" cy="256032"/>
+            <a:off x="5041677" y="2743200"/>
+            <a:ext cx="544735" cy="256032"/>
           </a:xfrm>
           <a:prstGeom prst="rect">
             <a:avLst/>
@@ -33284,7 +33284,7 @@
         <p:spPr>
           <a:xfrm>
             <a:off x="1188720" y="3063240"/>
-            <a:ext cx="1086403" cy="256032"/>
+            <a:ext cx="1152277" cy="256032"/>
           </a:xfrm>
           <a:prstGeom prst="rect">
             <a:avLst/>
@@ -33303,8 +33303,8 @@
         </p:nvSpPr>
         <p:spPr>
           <a:xfrm>
-            <a:off x="2275123" y="3063240"/>
-            <a:ext cx="1532777" cy="256032"/>
+            <a:off x="2340997" y="3063240"/>
+            <a:ext cx="956642" cy="256032"/>
           </a:xfrm>
           <a:prstGeom prst="rect">
             <a:avLst/>
@@ -33323,8 +33323,8 @@
         </p:nvSpPr>
         <p:spPr>
           <a:xfrm>
-            <a:off x="3807900" y="3063240"/>
-            <a:ext cx="573570" cy="256032"/>
+            <a:off x="3297639" y="3063240"/>
+            <a:ext cx="893773" cy="256032"/>
           </a:xfrm>
           <a:prstGeom prst="rect">
             <a:avLst/>
@@ -33343,8 +33343,8 @@
         </p:nvSpPr>
         <p:spPr>
           <a:xfrm>
-            <a:off x="4381470" y="3063240"/>
-            <a:ext cx="822077" cy="256032"/>
+            <a:off x="4191412" y="3063240"/>
+            <a:ext cx="789678" cy="256032"/>
           </a:xfrm>
           <a:prstGeom prst="rect">
             <a:avLst/>
@@ -33363,8 +33363,8 @@
         </p:nvSpPr>
         <p:spPr>
           <a:xfrm>
-            <a:off x="5203546" y="3063240"/>
-            <a:ext cx="338444" cy="256032"/>
+            <a:off x="4981090" y="3063240"/>
+            <a:ext cx="371425" cy="256032"/>
           </a:xfrm>
           <a:prstGeom prst="rect">
             <a:avLst/>
@@ -33423,7 +33423,7 @@
         <p:spPr>
           <a:xfrm>
             <a:off x="1188720" y="3383280"/>
-            <a:ext cx="973834" cy="256032"/>
+            <a:ext cx="996774" cy="256032"/>
           </a:xfrm>
           <a:prstGeom prst="rect">
             <a:avLst/>
@@ -33442,8 +33442,8 @@
         </p:nvSpPr>
         <p:spPr>
           <a:xfrm>
-            <a:off x="2162554" y="3383280"/>
-            <a:ext cx="1284680" cy="256032"/>
+            <a:off x="2185494" y="3383280"/>
+            <a:ext cx="1103021" cy="256032"/>
           </a:xfrm>
           <a:prstGeom prst="rect">
             <a:avLst/>
@@ -33462,8 +33462,8 @@
         </p:nvSpPr>
         <p:spPr>
           <a:xfrm>
-            <a:off x="3447234" y="3383280"/>
-            <a:ext cx="565829" cy="256032"/>
+            <a:off x="3288516" y="3383280"/>
+            <a:ext cx="715998" cy="256032"/>
           </a:xfrm>
           <a:prstGeom prst="rect">
             <a:avLst/>
@@ -33482,8 +33482,8 @@
         </p:nvSpPr>
         <p:spPr>
           <a:xfrm>
-            <a:off x="4013063" y="3383280"/>
-            <a:ext cx="535402" cy="256032"/>
+            <a:off x="4004514" y="3383280"/>
+            <a:ext cx="893549" cy="256032"/>
           </a:xfrm>
           <a:prstGeom prst="rect">
             <a:avLst/>
@@ -33502,8 +33502,8 @@
         </p:nvSpPr>
         <p:spPr>
           <a:xfrm>
-            <a:off x="4548465" y="3383280"/>
-            <a:ext cx="477411" cy="256032"/>
+            <a:off x="4898063" y="3383280"/>
+            <a:ext cx="537503" cy="256032"/>
           </a:xfrm>
           <a:prstGeom prst="rect">
             <a:avLst/>
@@ -34520,7 +34520,7 @@
                 <a:ea typeface="Georgia" pitchFamily="34" charset="-122"/>
                 <a:cs typeface="Georgia" pitchFamily="34" charset="-120"/>
               </a:rPr>
-              <a:t>The Epistasis Matrix</a:t>
+              <a:t>The Influence Matrix</a:t>
             </a:r>
             <a:endParaRPr lang="en-US" sz="2200" dirty="0"/>
           </a:p>
@@ -36333,7 +36333,7 @@
                 <a:ea typeface="Calibri" pitchFamily="34" charset="-122"/>
                 <a:cs typeface="Calibri" pitchFamily="34" charset="-120"/>
               </a:rPr>
-              <a:t>The epistasis matrix controls landscape ruggedness -- just like in classic NK, but here it co-evolves with the actors.</a:t>
+              <a:t>The influence matrix W is the model input that sets landscape ruggedness -- just like classic NK. You fix W; what co-evolves with the actors is the realized coupling K_CC and the fitness it drives.</a:t>
             </a:r>
             <a:endParaRPr lang="en-US" sz="1100" dirty="0"/>
           </a:p>

</xml_diff>